<commit_message>
Session 8: frame round 2 as an independent read, drop "colder"
The "not a colder read" line on slide 7 was left over from an earlier
design where round 1 was read by someone who knew the project. Students
had no reference for it. The slide, its presenter note, and the outline
now say only what matters: the round-2 reader never saw round 1's notes.

Co-Authored-By: Claude Opus 5.5 (1M context) <noreply@anthropic.com>
</commit_message>
<xml_diff>
--- a/canvas_material/lectures/powerpoint/Session08-PeerReview.pptx
+++ b/canvas_material/lectures/powerpoint/Session08-PeerReview.pptx
@@ -1305,7 +1305,7 @@
           <a:p>
             <a:r>
               <a:rPr lang="en-US" dirty="0"/>
-              <a:t>One minute before the second round. Correct the assumption students bring in: both readers are cold, so round 2 is not a harder audience — it is an independent replication. Teach the inference, because it transfers to code review and user research alike: agreement between two people who never spoke is evidence about the artifact; a lone flag is ambiguous and worth checking, not discarding. Then the recruiting question. A proposal can be technically sound and still attract nobody, and Pitch Day is a week out — tell reviewers an honest no with a reason is the most useful thing they can hand a classmate today.</a:t>
+              <a:t>One minute before the second round. The point of round 2 is independence: a new reader who hasn't seen round 1's marks is an independent replication. Teach the inference, because it transfers to code review and user research alike: agreement between two people who never spoke is evidence about the artifact; a lone flag is ambiguous and worth checking, not discarding. Then the recruiting question. A proposal can be technically sound and still attract nobody, and Pitch Day is a week out — tell reviewers an honest no with a reason is the most useful thing they can hand a classmate today.</a:t>
             </a:r>
             <a:endParaRPr lang="en-US" dirty="0"/>
           </a:p>
@@ -8969,7 +8969,7 @@
                 <a:ea typeface="Calibri" pitchFamily="34" charset="-122"/>
                 <a:cs typeface="Calibri" pitchFamily="34" charset="-120"/>
               </a:rPr>
-              <a:t>Both of your readers come in cold — that is the design. What round 2 buys you is not a colder read, it is an </a:t>
+              <a:t>Your round-2 reader never saw round 1’s notes. What that buys you is an </a:t>
             </a:r>
             <a:pPr indent="0" marL="0">
               <a:lnSpc>
@@ -9003,7 +9003,7 @@
                 <a:ea typeface="Calibri" pitchFamily="34" charset="-122"/>
                 <a:cs typeface="Calibri" pitchFamily="34" charset="-120"/>
               </a:rPr>
-              <a:t> one.</a:t>
+              <a:t> read — a check on whether each note is about your proposal or about the person who wrote it.</a:t>
             </a:r>
             <a:endParaRPr lang="en-US" sz="1700" dirty="0"/>
           </a:p>

</xml_diff>